<commit_message>
tweaked m8 async slides
</commit_message>
<xml_diff>
--- a/Slides/Module 08 Concurrency Patterns in Typescript.pptx
+++ b/Slides/Module 08 Concurrency Patterns in Typescript.pptx
@@ -5,7 +5,7 @@
     <p:sldMasterId id="2147483703" r:id="rId1"/>
   </p:sldMasterIdLst>
   <p:notesMasterIdLst>
-    <p:notesMasterId r:id="rId41"/>
+    <p:notesMasterId r:id="rId42"/>
   </p:notesMasterIdLst>
   <p:sldIdLst>
     <p:sldId id="485" r:id="rId2"/>
@@ -40,13 +40,14 @@
     <p:sldId id="594" r:id="rId31"/>
     <p:sldId id="560" r:id="rId32"/>
     <p:sldId id="664" r:id="rId33"/>
-    <p:sldId id="629" r:id="rId34"/>
-    <p:sldId id="277" r:id="rId35"/>
-    <p:sldId id="544" r:id="rId36"/>
-    <p:sldId id="499" r:id="rId37"/>
-    <p:sldId id="550" r:id="rId38"/>
-    <p:sldId id="546" r:id="rId39"/>
-    <p:sldId id="604" r:id="rId40"/>
+    <p:sldId id="690" r:id="rId34"/>
+    <p:sldId id="629" r:id="rId35"/>
+    <p:sldId id="277" r:id="rId36"/>
+    <p:sldId id="544" r:id="rId37"/>
+    <p:sldId id="499" r:id="rId38"/>
+    <p:sldId id="550" r:id="rId39"/>
+    <p:sldId id="546" r:id="rId40"/>
+    <p:sldId id="604" r:id="rId41"/>
   </p:sldIdLst>
   <p:sldSz cx="12192000" cy="6858000"/>
   <p:notesSz cx="6858000" cy="9144000"/>
@@ -385,6 +386,7 @@
             <p14:sldId id="594"/>
             <p14:sldId id="560"/>
             <p14:sldId id="664"/>
+            <p14:sldId id="690"/>
             <p14:sldId id="629"/>
             <p14:sldId id="277"/>
             <p14:sldId id="544"/>
@@ -2571,44 +2573,201 @@
           <a:bodyPr/>
           <a:lstStyle/>
           <a:p>
-            <a:pPr algn="l"/>
-            <a:r>
-              <a:rPr lang="en-US" dirty="0">
-                <a:solidFill>
-                  <a:schemeClr val="tx1"/>
-                </a:solidFill>
-              </a:rPr>
-              <a:t>Courtesy of </a:t>
-            </a:r>
-            <a:r>
-              <a:rPr lang="en-US" dirty="0">
-                <a:solidFill>
-                  <a:schemeClr val="tx1"/>
-                </a:solidFill>
-                <a:hlinkClick r:id="rId3"/>
-              </a:rPr>
-              <a:t>https://dev.to/lydiahallie/javascript-visualized-event-loop-3dif</a:t>
-            </a:r>
-            <a:endParaRPr lang="en-US" dirty="0">
-              <a:solidFill>
-                <a:schemeClr val="tx1"/>
-              </a:solidFill>
-            </a:endParaRPr>
-          </a:p>
-          <a:p>
-            <a:pPr algn="l"/>
-            <a:endParaRPr lang="en-US" dirty="0">
-              <a:solidFill>
-                <a:schemeClr val="tx1"/>
-              </a:solidFill>
-            </a:endParaRPr>
+            <a:r>
+              <a:rPr lang="en-US" sz="800" dirty="0"/>
+              <a:t>JavaScript microtasks (Promises, </a:t>
+            </a:r>
+            <a:r>
+              <a:rPr lang="en-US" sz="800" dirty="0" err="1"/>
+              <a:t>MutationObserver</a:t>
+            </a:r>
+            <a:r>
+              <a:rPr lang="en-US" sz="800" dirty="0"/>
+              <a:t>) have higher priority than </a:t>
+            </a:r>
+            <a:r>
+              <a:rPr lang="en-US" sz="800" dirty="0" err="1"/>
+              <a:t>macrotasks</a:t>
+            </a:r>
+            <a:r>
+              <a:rPr lang="en-US" sz="800" dirty="0"/>
+              <a:t> (</a:t>
+            </a:r>
+            <a:r>
+              <a:rPr lang="en-US" sz="800" dirty="0" err="1"/>
+              <a:t>setTimeout</a:t>
+            </a:r>
+            <a:r>
+              <a:rPr lang="en-US" sz="800" dirty="0"/>
+              <a:t>, I/O), executing immediately after the call stack empties and before the next event loop iteration. The event loop processes all available microtasks before running a single </a:t>
+            </a:r>
+            <a:r>
+              <a:rPr lang="en-US" sz="800" dirty="0" err="1"/>
+              <a:t>macrotask</a:t>
+            </a:r>
+            <a:r>
+              <a:rPr lang="en-US" sz="800" dirty="0"/>
+              <a:t>. </a:t>
+            </a:r>
+          </a:p>
+          <a:p>
+            <a:endParaRPr lang="en-US" sz="800" dirty="0"/>
+          </a:p>
+          <a:p>
+            <a:r>
+              <a:rPr lang="en-US" sz="800" dirty="0"/>
+              <a:t>Key Differences at a Glance:</a:t>
+            </a:r>
+          </a:p>
+          <a:p>
+            <a:r>
+              <a:rPr lang="en-US" sz="800" dirty="0"/>
+              <a:t>Priority: Microtasks are executed immediately after the current task and before the browser renders, while </a:t>
+            </a:r>
+            <a:r>
+              <a:rPr lang="en-US" sz="800" dirty="0" err="1"/>
+              <a:t>macrotasks</a:t>
+            </a:r>
+            <a:r>
+              <a:rPr lang="en-US" sz="800" dirty="0"/>
+              <a:t> are processed one by one, allowing rendering to happen between them.</a:t>
+            </a:r>
+          </a:p>
+          <a:p>
+            <a:r>
+              <a:rPr lang="en-US" sz="800" dirty="0"/>
+              <a:t>Order: If a microtask adds another microtask, it is executed in the same cycle. If a </a:t>
+            </a:r>
+            <a:r>
+              <a:rPr lang="en-US" sz="800" dirty="0" err="1"/>
+              <a:t>macrotask</a:t>
+            </a:r>
+            <a:r>
+              <a:rPr lang="en-US" sz="800" dirty="0"/>
+              <a:t> adds a microtask, it is also executed before the next </a:t>
+            </a:r>
+            <a:r>
+              <a:rPr lang="en-US" sz="800" dirty="0" err="1"/>
+              <a:t>macrotask</a:t>
+            </a:r>
+            <a:r>
+              <a:rPr lang="en-US" sz="800" dirty="0"/>
+              <a:t>.</a:t>
+            </a:r>
+          </a:p>
+          <a:p>
+            <a:r>
+              <a:rPr lang="en-US" sz="800" dirty="0"/>
+              <a:t>Usage: Microtasks are for urgent, immediate post-processing (e.g., Promise resolutions). </a:t>
+            </a:r>
+            <a:r>
+              <a:rPr lang="en-US" sz="800" dirty="0" err="1"/>
+              <a:t>Macrotasks</a:t>
+            </a:r>
+            <a:r>
+              <a:rPr lang="en-US" sz="800" dirty="0"/>
+              <a:t> are for slower, asynchronous operations (e.g., </a:t>
+            </a:r>
+            <a:r>
+              <a:rPr lang="en-US" sz="800" dirty="0" err="1"/>
+              <a:t>setInterval</a:t>
+            </a:r>
+            <a:r>
+              <a:rPr lang="en-US" sz="800" dirty="0"/>
+              <a:t>, </a:t>
+            </a:r>
+            <a:r>
+              <a:rPr lang="en-US" sz="800" dirty="0" err="1"/>
+              <a:t>fs.readFile</a:t>
+            </a:r>
+            <a:r>
+              <a:rPr lang="en-US" sz="800" dirty="0"/>
+              <a:t> in Node.js). </a:t>
+            </a:r>
+          </a:p>
+          <a:p>
+            <a:endParaRPr lang="en-US" sz="800" dirty="0"/>
+          </a:p>
+          <a:p>
+            <a:r>
+              <a:rPr lang="en-US" sz="800" dirty="0"/>
+              <a:t>Examples of Tasks</a:t>
+            </a:r>
+          </a:p>
+          <a:p>
+            <a:r>
+              <a:rPr lang="en-US" sz="800" dirty="0"/>
+              <a:t>    Microtasks: Promise callbacks (.then/.catch/.finally), </a:t>
+            </a:r>
+            <a:r>
+              <a:rPr lang="en-US" sz="800" dirty="0" err="1"/>
+              <a:t>queueMicrotask</a:t>
+            </a:r>
+            <a:r>
+              <a:rPr lang="en-US" sz="800" dirty="0"/>
+              <a:t>(), </a:t>
+            </a:r>
+            <a:r>
+              <a:rPr lang="en-US" sz="800" dirty="0" err="1"/>
+              <a:t>MutationObserver</a:t>
+            </a:r>
+            <a:r>
+              <a:rPr lang="en-US" sz="800" dirty="0"/>
+              <a:t>.</a:t>
+            </a:r>
+          </a:p>
+          <a:p>
+            <a:r>
+              <a:rPr lang="en-US" sz="800" dirty="0"/>
+              <a:t>    </a:t>
+            </a:r>
+            <a:r>
+              <a:rPr lang="en-US" sz="800" dirty="0" err="1"/>
+              <a:t>Macrotasks</a:t>
+            </a:r>
+            <a:r>
+              <a:rPr lang="en-US" sz="800" dirty="0"/>
+              <a:t>: </a:t>
+            </a:r>
+            <a:r>
+              <a:rPr lang="en-US" sz="800" dirty="0" err="1"/>
+              <a:t>setTimeout</a:t>
+            </a:r>
+            <a:r>
+              <a:rPr lang="en-US" sz="800" dirty="0"/>
+              <a:t>(), </a:t>
+            </a:r>
+            <a:r>
+              <a:rPr lang="en-US" sz="800" dirty="0" err="1"/>
+              <a:t>setInterval</a:t>
+            </a:r>
+            <a:r>
+              <a:rPr lang="en-US" sz="800" dirty="0"/>
+              <a:t>(), </a:t>
+            </a:r>
+            <a:r>
+              <a:rPr lang="en-US" sz="800" dirty="0" err="1"/>
+              <a:t>setImmediate</a:t>
+            </a:r>
+            <a:r>
+              <a:rPr lang="en-US" sz="800" dirty="0"/>
+              <a:t>() (Node.js), I/O operations, UI rendering events, </a:t>
+            </a:r>
+            <a:r>
+              <a:rPr lang="en-US" sz="800" dirty="0" err="1"/>
+              <a:t>EventHandler</a:t>
+            </a:r>
+            <a:r>
+              <a:rPr lang="en-US" sz="800" dirty="0"/>
+              <a:t> Callbacks </a:t>
+            </a:r>
           </a:p>
         </p:txBody>
       </p:sp>
     </p:spTree>
     <p:extLst>
       <p:ext uri="{BB962C8B-B14F-4D97-AF65-F5344CB8AC3E}">
-        <p14:creationId xmlns:p14="http://schemas.microsoft.com/office/powerpoint/2010/main" val="3636221697"/>
+        <p14:creationId xmlns:p14="http://schemas.microsoft.com/office/powerpoint/2010/main" val="1262714736"/>
       </p:ext>
     </p:extLst>
   </p:cSld>
@@ -2662,14 +2821,44 @@
           <a:bodyPr/>
           <a:lstStyle/>
           <a:p>
-            <a:endParaRPr lang="en-US" dirty="0"/>
+            <a:pPr algn="l"/>
+            <a:r>
+              <a:rPr lang="en-US" dirty="0">
+                <a:solidFill>
+                  <a:schemeClr val="tx1"/>
+                </a:solidFill>
+              </a:rPr>
+              <a:t>Courtesy of </a:t>
+            </a:r>
+            <a:r>
+              <a:rPr lang="en-US" dirty="0">
+                <a:solidFill>
+                  <a:schemeClr val="tx1"/>
+                </a:solidFill>
+                <a:hlinkClick r:id="rId3"/>
+              </a:rPr>
+              <a:t>https://dev.to/lydiahallie/javascript-visualized-event-loop-3dif</a:t>
+            </a:r>
+            <a:endParaRPr lang="en-US" dirty="0">
+              <a:solidFill>
+                <a:schemeClr val="tx1"/>
+              </a:solidFill>
+            </a:endParaRPr>
+          </a:p>
+          <a:p>
+            <a:pPr algn="l"/>
+            <a:endParaRPr lang="en-US" dirty="0">
+              <a:solidFill>
+                <a:schemeClr val="tx1"/>
+              </a:solidFill>
+            </a:endParaRPr>
           </a:p>
         </p:txBody>
       </p:sp>
     </p:spTree>
     <p:extLst>
       <p:ext uri="{BB962C8B-B14F-4D97-AF65-F5344CB8AC3E}">
-        <p14:creationId xmlns:p14="http://schemas.microsoft.com/office/powerpoint/2010/main" val="358283542"/>
+        <p14:creationId xmlns:p14="http://schemas.microsoft.com/office/powerpoint/2010/main" val="3636221697"/>
       </p:ext>
     </p:extLst>
   </p:cSld>
@@ -2830,7 +3019,7 @@
     </p:spTree>
     <p:extLst>
       <p:ext uri="{BB962C8B-B14F-4D97-AF65-F5344CB8AC3E}">
-        <p14:creationId xmlns:p14="http://schemas.microsoft.com/office/powerpoint/2010/main" val="1096998824"/>
+        <p14:creationId xmlns:p14="http://schemas.microsoft.com/office/powerpoint/2010/main" val="358283542"/>
       </p:ext>
     </p:extLst>
   </p:cSld>
@@ -2884,42 +3073,14 @@
           <a:bodyPr/>
           <a:lstStyle/>
           <a:p>
-            <a:r>
-              <a:rPr lang="en-US" dirty="0"/>
-              <a:t>Promises enforce the order of operations only through the .then. The code in the ‘then’ won’t run until the promise is resolved.  Note that every .then() is a choice point, allowing the runtime to switch to some other task.</a:t>
-            </a:r>
-          </a:p>
-          <a:p>
-            <a:br>
-              <a:rPr lang="en-US" dirty="0"/>
-            </a:br>
-            <a:r>
-              <a:rPr lang="en-US" dirty="0"/>
-              <a:t>(build through example, explaining the possible orders of results. Point out that we should never depend on the order of results we hear back form google/</a:t>
-            </a:r>
-            <a:r>
-              <a:rPr lang="en-US" dirty="0" err="1"/>
-              <a:t>facebook</a:t>
-            </a:r>
-            <a:r>
-              <a:rPr lang="en-US" dirty="0"/>
-              <a:t>/</a:t>
-            </a:r>
-            <a:r>
-              <a:rPr lang="en-US" dirty="0" err="1"/>
-              <a:t>coveytown</a:t>
-            </a:r>
-            <a:r>
-              <a:rPr lang="en-US" dirty="0"/>
-              <a:t> because it is non-deterministic. You might happen to see 9/10 times one ordering, but there is no guarantee)</a:t>
-            </a:r>
+            <a:endParaRPr lang="en-US" dirty="0"/>
           </a:p>
         </p:txBody>
       </p:sp>
     </p:spTree>
     <p:extLst>
       <p:ext uri="{BB962C8B-B14F-4D97-AF65-F5344CB8AC3E}">
-        <p14:creationId xmlns:p14="http://schemas.microsoft.com/office/powerpoint/2010/main" val="939291855"/>
+        <p14:creationId xmlns:p14="http://schemas.microsoft.com/office/powerpoint/2010/main" val="1096998824"/>
       </p:ext>
     </p:extLst>
   </p:cSld>
@@ -2975,21 +3136,40 @@
           <a:p>
             <a:r>
               <a:rPr lang="en-US" dirty="0"/>
-              <a:t>We've already seen non-deterministic behavior reflected in our console logs.  But that kind of behavior can easily become visible to our program.  All you need is some shared state across your promises.</a:t>
-            </a:r>
-          </a:p>
-          <a:p>
-            <a:endParaRPr lang="en-US" dirty="0"/>
-          </a:p>
-          <a:p>
-            <a:endParaRPr lang="en-US" dirty="0"/>
+              <a:t>Promises enforce the order of operations only through the .then. The code in the ‘then’ won’t run until the promise is resolved.  Note that every .then() is a choice point, allowing the runtime to switch to some other task.</a:t>
+            </a:r>
+          </a:p>
+          <a:p>
+            <a:br>
+              <a:rPr lang="en-US" dirty="0"/>
+            </a:br>
+            <a:r>
+              <a:rPr lang="en-US" dirty="0"/>
+              <a:t>(build through example, explaining the possible orders of results. Point out that we should never depend on the order of results we hear back form google/</a:t>
+            </a:r>
+            <a:r>
+              <a:rPr lang="en-US" dirty="0" err="1"/>
+              <a:t>facebook</a:t>
+            </a:r>
+            <a:r>
+              <a:rPr lang="en-US" dirty="0"/>
+              <a:t>/</a:t>
+            </a:r>
+            <a:r>
+              <a:rPr lang="en-US" dirty="0" err="1"/>
+              <a:t>coveytown</a:t>
+            </a:r>
+            <a:r>
+              <a:rPr lang="en-US" dirty="0"/>
+              <a:t> because it is non-deterministic. You might happen to see 9/10 times one ordering, but there is no guarantee)</a:t>
+            </a:r>
           </a:p>
         </p:txBody>
       </p:sp>
     </p:spTree>
     <p:extLst>
       <p:ext uri="{BB962C8B-B14F-4D97-AF65-F5344CB8AC3E}">
-        <p14:creationId xmlns:p14="http://schemas.microsoft.com/office/powerpoint/2010/main" val="3094308994"/>
+        <p14:creationId xmlns:p14="http://schemas.microsoft.com/office/powerpoint/2010/main" val="939291855"/>
       </p:ext>
     </p:extLst>
   </p:cSld>
@@ -3045,6 +3225,76 @@
           <a:p>
             <a:r>
               <a:rPr lang="en-US" dirty="0"/>
+              <a:t>We've already seen non-deterministic behavior reflected in our console logs.  But that kind of behavior can easily become visible to our program.  All you need is some shared state across your promises.</a:t>
+            </a:r>
+          </a:p>
+          <a:p>
+            <a:endParaRPr lang="en-US" dirty="0"/>
+          </a:p>
+          <a:p>
+            <a:endParaRPr lang="en-US" dirty="0"/>
+          </a:p>
+        </p:txBody>
+      </p:sp>
+    </p:spTree>
+    <p:extLst>
+      <p:ext uri="{BB962C8B-B14F-4D97-AF65-F5344CB8AC3E}">
+        <p14:creationId xmlns:p14="http://schemas.microsoft.com/office/powerpoint/2010/main" val="3094308994"/>
+      </p:ext>
+    </p:extLst>
+  </p:cSld>
+  <p:clrMapOvr>
+    <a:masterClrMapping/>
+  </p:clrMapOvr>
+</p:notes>
+</file>
+
+<file path=ppt/notesSlides/notesSlide34.xml><?xml version="1.0" encoding="utf-8"?>
+<p:notes xmlns:a="http://schemas.openxmlformats.org/drawingml/2006/main" xmlns:r="http://schemas.openxmlformats.org/officeDocument/2006/relationships" xmlns:p="http://schemas.openxmlformats.org/presentationml/2006/main">
+  <p:cSld>
+    <p:spTree>
+      <p:nvGrpSpPr>
+        <p:cNvPr id="1" name=""/>
+        <p:cNvGrpSpPr/>
+        <p:nvPr/>
+      </p:nvGrpSpPr>
+      <p:grpSpPr>
+        <a:xfrm>
+          <a:off x="0" y="0"/>
+          <a:ext cx="0" cy="0"/>
+          <a:chOff x="0" y="0"/>
+          <a:chExt cx="0" cy="0"/>
+        </a:xfrm>
+      </p:grpSpPr>
+      <p:sp>
+        <p:nvSpPr>
+          <p:cNvPr id="2" name="Slide Image Placeholder 1"/>
+          <p:cNvSpPr>
+            <a:spLocks noGrp="1" noRot="1" noChangeAspect="1"/>
+          </p:cNvSpPr>
+          <p:nvPr>
+            <p:ph type="sldImg"/>
+          </p:nvPr>
+        </p:nvSpPr>
+        <p:spPr/>
+      </p:sp>
+      <p:sp>
+        <p:nvSpPr>
+          <p:cNvPr id="3" name="Notes Placeholder 2"/>
+          <p:cNvSpPr>
+            <a:spLocks noGrp="1"/>
+          </p:cNvSpPr>
+          <p:nvPr>
+            <p:ph type="body" idx="1"/>
+          </p:nvPr>
+        </p:nvSpPr>
+        <p:spPr/>
+        <p:txBody>
+          <a:bodyPr/>
+          <a:lstStyle/>
+          <a:p>
+            <a:r>
+              <a:rPr lang="en-US" dirty="0"/>
               <a:t>&lt;read slide&gt;</a:t>
             </a:r>
           </a:p>
@@ -3067,7 +3317,7 @@
           <a:p>
             <a:fld id="{07937F07-1250-4CCE-B198-1B2887014F41}" type="slidenum">
               <a:rPr lang="en-US" smtClean="0"/>
-              <a:t>39</a:t>
+              <a:t>40</a:t>
             </a:fld>
             <a:endParaRPr lang="en-US"/>
           </a:p>
@@ -15258,13 +15508,13 @@
         </p:nvSpPr>
         <p:spPr>
           <a:xfrm>
-            <a:off x="733302" y="3490384"/>
+            <a:off x="733302" y="3254361"/>
             <a:ext cx="11155326" cy="2755213"/>
           </a:xfrm>
         </p:spPr>
         <p:txBody>
           <a:bodyPr>
-            <a:normAutofit fontScale="92500" lnSpcReduction="20000"/>
+            <a:normAutofit fontScale="85000" lnSpcReduction="10000"/>
           </a:bodyPr>
           <a:lstStyle/>
           <a:p>
@@ -15284,15 +15534,15 @@
             </a:pPr>
             <a:r>
               <a:rPr lang="en-US" dirty="0"/>
-              <a:t>The http request is sent, using non-blocking </a:t>
-            </a:r>
-            <a:r>
-              <a:rPr lang="en-US" dirty="0" err="1"/>
-              <a:t>i</a:t>
+              <a:t>The http request is </a:t>
+            </a:r>
+            <a:r>
+              <a:rPr lang="en-US" i="1" dirty="0"/>
+              <a:t>immediately</a:t>
             </a:r>
             <a:r>
               <a:rPr lang="en-US" dirty="0"/>
-              <a:t>/o</a:t>
+              <a:t> sent, using non-blocking i/o. The browser goes about its business</a:t>
             </a:r>
           </a:p>
           <a:p>
@@ -15302,7 +15552,7 @@
             </a:pPr>
             <a:r>
               <a:rPr lang="en-US" dirty="0"/>
-              <a:t>The browser goes about its business</a:t>
+              <a:t>A pending promise is returned to the caller.</a:t>
             </a:r>
           </a:p>
           <a:p>
@@ -16068,7 +16318,7 @@
         <p:spPr>
           <a:xfrm>
             <a:off x="736600" y="1350065"/>
-            <a:ext cx="9573260" cy="5632311"/>
+            <a:ext cx="9573260" cy="5078313"/>
           </a:xfrm>
           <a:prstGeom prst="rect">
             <a:avLst/>
@@ -16913,25 +17163,6 @@
               </a:rPr>
               <a:t>make3ConcurrentRequests()</a:t>
             </a:r>
-          </a:p>
-          <a:p>
-            <a:pPr algn="l"/>
-            <a:br>
-              <a:rPr lang="en-US" sz="1800" b="0" dirty="0">
-                <a:solidFill>
-                  <a:srgbClr val="000000"/>
-                </a:solidFill>
-                <a:effectLst/>
-                <a:latin typeface="Consolas" panose="020B0609020204030204" pitchFamily="49" charset="0"/>
-              </a:rPr>
-            </a:br>
-            <a:endParaRPr lang="en-US" sz="1800" b="0" dirty="0">
-              <a:solidFill>
-                <a:srgbClr val="000000"/>
-              </a:solidFill>
-              <a:effectLst/>
-              <a:latin typeface="Consolas" panose="020B0609020204030204" pitchFamily="49" charset="0"/>
-            </a:endParaRPr>
           </a:p>
         </p:txBody>
       </p:sp>
@@ -18848,7 +19079,7 @@
         </p:nvSpPr>
         <p:spPr>
           <a:xfrm>
-            <a:off x="7041446" y="5430379"/>
+            <a:off x="7041446" y="5311949"/>
             <a:ext cx="2189747" cy="661737"/>
           </a:xfrm>
           <a:prstGeom prst="ellipse">
@@ -19942,7 +20173,7 @@
         </p:nvSpPr>
         <p:spPr>
           <a:xfrm>
-            <a:off x="6608309" y="5683156"/>
+            <a:off x="6608309" y="5618765"/>
             <a:ext cx="2189747" cy="661737"/>
           </a:xfrm>
           <a:prstGeom prst="ellipse">
@@ -20550,7 +20781,7 @@
 </file>
 
 <file path=ppt/slides/slide19.xml><?xml version="1.0" encoding="utf-8"?>
-<p:sld xmlns:a="http://schemas.openxmlformats.org/drawingml/2006/main" xmlns:r="http://schemas.openxmlformats.org/officeDocument/2006/relationships" xmlns:p="http://schemas.openxmlformats.org/presentationml/2006/main">
+<p:sld xmlns:a="http://schemas.openxmlformats.org/drawingml/2006/main" xmlns:r="http://schemas.openxmlformats.org/officeDocument/2006/relationships" xmlns:p="http://schemas.openxmlformats.org/presentationml/2006/main" show="0">
   <p:cSld>
     <p:spTree>
       <p:nvGrpSpPr>
@@ -30842,7 +31073,7 @@
 </file>
 
 <file path=ppt/slides/slide26.xml><?xml version="1.0" encoding="utf-8"?>
-<p:sld xmlns:a="http://schemas.openxmlformats.org/drawingml/2006/main" xmlns:r="http://schemas.openxmlformats.org/officeDocument/2006/relationships" xmlns:p="http://schemas.openxmlformats.org/presentationml/2006/main">
+<p:sld xmlns:a="http://schemas.openxmlformats.org/drawingml/2006/main" xmlns:r="http://schemas.openxmlformats.org/officeDocument/2006/relationships" xmlns:p="http://schemas.openxmlformats.org/presentationml/2006/main" show="0">
   <p:cSld>
     <p:spTree>
       <p:nvGrpSpPr>
@@ -31452,7 +31683,7 @@
 </file>
 
 <file path=ppt/slides/slide27.xml><?xml version="1.0" encoding="utf-8"?>
-<p:sld xmlns:a="http://schemas.openxmlformats.org/drawingml/2006/main" xmlns:r="http://schemas.openxmlformats.org/officeDocument/2006/relationships" xmlns:p="http://schemas.openxmlformats.org/presentationml/2006/main">
+<p:sld xmlns:a="http://schemas.openxmlformats.org/drawingml/2006/main" xmlns:r="http://schemas.openxmlformats.org/officeDocument/2006/relationships" xmlns:p="http://schemas.openxmlformats.org/presentationml/2006/main" show="0">
   <p:cSld>
     <p:spTree>
       <p:nvGrpSpPr>
@@ -34898,12 +35129,22 @@
         </p:nvSpPr>
         <p:spPr/>
         <p:txBody>
-          <a:bodyPr/>
+          <a:bodyPr>
+            <a:normAutofit/>
+          </a:bodyPr>
           <a:lstStyle/>
           <a:p>
             <a:r>
               <a:rPr lang="en-US" dirty="0"/>
-              <a:t>Here is a quick demo for you</a:t>
+              <a:t>Microtasks are urgent and </a:t>
+            </a:r>
+            <a:r>
+              <a:rPr lang="en-US" dirty="0" err="1"/>
+              <a:t>Macrotasks</a:t>
+            </a:r>
+            <a:r>
+              <a:rPr lang="en-US" dirty="0"/>
+              <a:t> are slower/asynchronous operations</a:t>
             </a:r>
           </a:p>
         </p:txBody>
@@ -34981,6 +35222,253 @@
                 <a:defRPr/>
               </a:pPr>
               <a:t>33</a:t>
+            </a:fld>
+            <a:endParaRPr kumimoji="0" lang="en-US" sz="1200" b="0" i="0" u="none" strike="noStrike" kern="1200" cap="none" spc="0" normalizeH="0" baseline="0" noProof="0">
+              <a:ln>
+                <a:noFill/>
+              </a:ln>
+              <a:solidFill>
+                <a:prstClr val="black">
+                  <a:tint val="75000"/>
+                </a:prstClr>
+              </a:solidFill>
+              <a:effectLst/>
+              <a:uLnTx/>
+              <a:uFillTx/>
+              <a:latin typeface="Calibri" panose="020F0502020204030204"/>
+              <a:ea typeface="+mn-ea"/>
+              <a:cs typeface="+mn-cs"/>
+            </a:endParaRPr>
+          </a:p>
+        </p:txBody>
+      </p:sp>
+      <p:sp>
+        <p:nvSpPr>
+          <p:cNvPr id="10" name="Content Placeholder 1">
+            <a:extLst>
+              <a:ext uri="{FF2B5EF4-FFF2-40B4-BE49-F238E27FC236}">
+                <a16:creationId xmlns:a16="http://schemas.microsoft.com/office/drawing/2014/main" id="{C8607FDF-AE92-26C4-F259-B37D84C4E431}"/>
+              </a:ext>
+            </a:extLst>
+          </p:cNvPr>
+          <p:cNvSpPr>
+            <a:spLocks noGrp="1"/>
+          </p:cNvSpPr>
+          <p:nvPr>
+            <p:ph idx="1"/>
+          </p:nvPr>
+        </p:nvSpPr>
+        <p:spPr>
+          <a:xfrm>
+            <a:off x="838199" y="1500159"/>
+            <a:ext cx="5072743" cy="4769267"/>
+          </a:xfrm>
+        </p:spPr>
+        <p:txBody>
+          <a:bodyPr>
+            <a:normAutofit/>
+          </a:bodyPr>
+          <a:lstStyle/>
+          <a:p>
+            <a:r>
+              <a:rPr lang="en-US" dirty="0"/>
+              <a:t>Microtask queue is used for immediate/urgent tasks while </a:t>
+            </a:r>
+            <a:r>
+              <a:rPr lang="en-US" dirty="0" err="1"/>
+              <a:t>Macrotask</a:t>
+            </a:r>
+            <a:r>
+              <a:rPr lang="en-US" dirty="0"/>
+              <a:t> queue is used for slower asynchronous tasks.</a:t>
+            </a:r>
+          </a:p>
+          <a:p>
+            <a:r>
+              <a:rPr lang="en-US" dirty="0"/>
+              <a:t>When call stack is empty, microtask queue is processed first (before browser renders). When microtask queue is empty then microtask queue is processed.</a:t>
+            </a:r>
+          </a:p>
+        </p:txBody>
+      </p:sp>
+      <p:pic>
+        <p:nvPicPr>
+          <p:cNvPr id="1026" name="Picture 2" descr="Understanding the Call Stack, Microtask Queue, and Macrotask Queue in JavaScript">
+            <a:extLst>
+              <a:ext uri="{FF2B5EF4-FFF2-40B4-BE49-F238E27FC236}">
+                <a16:creationId xmlns:a16="http://schemas.microsoft.com/office/drawing/2014/main" id="{260730D6-DA97-1FE4-E903-8B30CB508CAF}"/>
+              </a:ext>
+            </a:extLst>
+          </p:cNvPr>
+          <p:cNvPicPr>
+            <a:picLocks noChangeAspect="1" noChangeArrowheads="1"/>
+          </p:cNvPicPr>
+          <p:nvPr/>
+        </p:nvPicPr>
+        <p:blipFill>
+          <a:blip r:embed="rId3">
+            <a:extLst>
+              <a:ext uri="{28A0092B-C50C-407E-A947-70E740481C1C}">
+                <a14:useLocalDpi xmlns:a14="http://schemas.microsoft.com/office/drawing/2010/main" val="0"/>
+              </a:ext>
+            </a:extLst>
+          </a:blip>
+          <a:srcRect/>
+          <a:stretch>
+            <a:fillRect/>
+          </a:stretch>
+        </p:blipFill>
+        <p:spPr bwMode="auto">
+          <a:xfrm>
+            <a:off x="6078311" y="1612446"/>
+            <a:ext cx="5275489" cy="2965230"/>
+          </a:xfrm>
+          <a:prstGeom prst="rect">
+            <a:avLst/>
+          </a:prstGeom>
+          <a:noFill/>
+          <a:extLst>
+            <a:ext uri="{909E8E84-426E-40DD-AFC4-6F175D3DCCD1}">
+              <a14:hiddenFill xmlns:a14="http://schemas.microsoft.com/office/drawing/2010/main">
+                <a:solidFill>
+                  <a:srgbClr val="FFFFFF"/>
+                </a:solidFill>
+              </a14:hiddenFill>
+            </a:ext>
+          </a:extLst>
+        </p:spPr>
+      </p:pic>
+    </p:spTree>
+    <p:extLst>
+      <p:ext uri="{BB962C8B-B14F-4D97-AF65-F5344CB8AC3E}">
+        <p14:creationId xmlns:p14="http://schemas.microsoft.com/office/powerpoint/2010/main" val="1806335483"/>
+      </p:ext>
+    </p:extLst>
+  </p:cSld>
+  <p:clrMapOvr>
+    <a:masterClrMapping/>
+  </p:clrMapOvr>
+</p:sld>
+</file>
+
+<file path=ppt/slides/slide34.xml><?xml version="1.0" encoding="utf-8"?>
+<p:sld xmlns:a="http://schemas.openxmlformats.org/drawingml/2006/main" xmlns:r="http://schemas.openxmlformats.org/officeDocument/2006/relationships" xmlns:p="http://schemas.openxmlformats.org/presentationml/2006/main">
+  <p:cSld>
+    <p:spTree>
+      <p:nvGrpSpPr>
+        <p:cNvPr id="1" name=""/>
+        <p:cNvGrpSpPr/>
+        <p:nvPr/>
+      </p:nvGrpSpPr>
+      <p:grpSpPr>
+        <a:xfrm>
+          <a:off x="0" y="0"/>
+          <a:ext cx="0" cy="0"/>
+          <a:chOff x="0" y="0"/>
+          <a:chExt cx="0" cy="0"/>
+        </a:xfrm>
+      </p:grpSpPr>
+      <p:sp>
+        <p:nvSpPr>
+          <p:cNvPr id="2" name="Title 1">
+            <a:extLst>
+              <a:ext uri="{FF2B5EF4-FFF2-40B4-BE49-F238E27FC236}">
+                <a16:creationId xmlns:a16="http://schemas.microsoft.com/office/drawing/2014/main" id="{29121F2F-6CF4-38E5-4111-58D01708C3D0}"/>
+              </a:ext>
+            </a:extLst>
+          </p:cNvPr>
+          <p:cNvSpPr>
+            <a:spLocks noGrp="1"/>
+          </p:cNvSpPr>
+          <p:nvPr>
+            <p:ph type="title"/>
+          </p:nvPr>
+        </p:nvSpPr>
+        <p:spPr/>
+        <p:txBody>
+          <a:bodyPr/>
+          <a:lstStyle/>
+          <a:p>
+            <a:r>
+              <a:rPr lang="en-US" dirty="0"/>
+              <a:t>Here is a quick demo for you</a:t>
+            </a:r>
+          </a:p>
+        </p:txBody>
+      </p:sp>
+      <p:sp>
+        <p:nvSpPr>
+          <p:cNvPr id="4" name="Slide Number Placeholder 3">
+            <a:extLst>
+              <a:ext uri="{FF2B5EF4-FFF2-40B4-BE49-F238E27FC236}">
+                <a16:creationId xmlns:a16="http://schemas.microsoft.com/office/drawing/2014/main" id="{04664315-99D5-1896-D0BB-CD09B9541421}"/>
+              </a:ext>
+            </a:extLst>
+          </p:cNvPr>
+          <p:cNvSpPr>
+            <a:spLocks noGrp="1"/>
+          </p:cNvSpPr>
+          <p:nvPr>
+            <p:ph type="sldNum" sz="quarter" idx="12"/>
+          </p:nvPr>
+        </p:nvSpPr>
+        <p:spPr/>
+        <p:txBody>
+          <a:bodyPr/>
+          <a:lstStyle/>
+          <a:p>
+            <a:pPr marL="0" marR="0" lvl="0" indent="0" algn="r" defTabSz="914400" rtl="0" eaLnBrk="1" fontAlgn="auto" latinLnBrk="0" hangingPunct="1">
+              <a:lnSpc>
+                <a:spcPct val="100000"/>
+              </a:lnSpc>
+              <a:spcBef>
+                <a:spcPts val="0"/>
+              </a:spcBef>
+              <a:spcAft>
+                <a:spcPts val="0"/>
+              </a:spcAft>
+              <a:buClrTx/>
+              <a:buSzTx/>
+              <a:buFontTx/>
+              <a:buNone/>
+              <a:tabLst/>
+              <a:defRPr/>
+            </a:pPr>
+            <a:fld id="{20F37917-FD3A-4669-9018-DA04BCDD3D75}" type="slidenum">
+              <a:rPr kumimoji="0" lang="en-US" sz="1200" b="0" i="0" u="none" strike="noStrike" kern="1200" cap="none" spc="0" normalizeH="0" baseline="0" noProof="0" smtClean="0">
+                <a:ln>
+                  <a:noFill/>
+                </a:ln>
+                <a:solidFill>
+                  <a:prstClr val="black">
+                    <a:tint val="75000"/>
+                  </a:prstClr>
+                </a:solidFill>
+                <a:effectLst/>
+                <a:uLnTx/>
+                <a:uFillTx/>
+                <a:latin typeface="Calibri" panose="020F0502020204030204"/>
+                <a:ea typeface="+mn-ea"/>
+                <a:cs typeface="+mn-cs"/>
+              </a:rPr>
+              <a:pPr marL="0" marR="0" lvl="0" indent="0" algn="r" defTabSz="914400" rtl="0" eaLnBrk="1" fontAlgn="auto" latinLnBrk="0" hangingPunct="1">
+                <a:lnSpc>
+                  <a:spcPct val="100000"/>
+                </a:lnSpc>
+                <a:spcBef>
+                  <a:spcPts val="0"/>
+                </a:spcBef>
+                <a:spcAft>
+                  <a:spcPts val="0"/>
+                </a:spcAft>
+                <a:buClrTx/>
+                <a:buSzTx/>
+                <a:buFontTx/>
+                <a:buNone/>
+                <a:tabLst/>
+                <a:defRPr/>
+              </a:pPr>
+              <a:t>34</a:t>
             </a:fld>
             <a:endParaRPr kumimoji="0" lang="en-US" sz="1200" b="0" i="0" u="none" strike="noStrike" kern="1200" cap="none" spc="0" normalizeH="0" baseline="0" noProof="0">
               <a:ln>
@@ -35238,7 +35726,7 @@
 </p:sld>
 </file>
 
-<file path=ppt/slides/slide34.xml><?xml version="1.0" encoding="utf-8"?>
+<file path=ppt/slides/slide35.xml><?xml version="1.0" encoding="utf-8"?>
 <p:sld xmlns:a="http://schemas.openxmlformats.org/drawingml/2006/main" xmlns:r="http://schemas.openxmlformats.org/officeDocument/2006/relationships" xmlns:p="http://schemas.openxmlformats.org/presentationml/2006/main">
   <p:cSld>
     <p:spTree>
@@ -35396,7 +35884,7 @@
 </p:sld>
 </file>
 
-<file path=ppt/slides/slide35.xml><?xml version="1.0" encoding="utf-8"?>
+<file path=ppt/slides/slide36.xml><?xml version="1.0" encoding="utf-8"?>
 <p:sld xmlns:a="http://schemas.openxmlformats.org/drawingml/2006/main" xmlns:r="http://schemas.openxmlformats.org/officeDocument/2006/relationships" xmlns:p="http://schemas.openxmlformats.org/presentationml/2006/main">
   <p:cSld>
     <p:spTree>
@@ -35513,7 +36001,7 @@
                 <a:tabLst/>
                 <a:defRPr/>
               </a:pPr>
-              <a:t>35</a:t>
+              <a:t>36</a:t>
             </a:fld>
             <a:endParaRPr kumimoji="0" lang="en-US" sz="1200" b="0" i="0" u="none" strike="noStrike" kern="1200" cap="none" spc="0" normalizeH="0" baseline="0" noProof="0">
               <a:ln>
@@ -35547,7 +36035,7 @@
 </p:sld>
 </file>
 
-<file path=ppt/slides/slide36.xml><?xml version="1.0" encoding="utf-8"?>
+<file path=ppt/slides/slide37.xml><?xml version="1.0" encoding="utf-8"?>
 <p:sld xmlns:a="http://schemas.openxmlformats.org/drawingml/2006/main" xmlns:r="http://schemas.openxmlformats.org/officeDocument/2006/relationships" xmlns:p="http://schemas.openxmlformats.org/presentationml/2006/main">
   <p:cSld>
     <p:spTree>
@@ -36561,7 +37049,7 @@
 </p:sld>
 </file>
 
-<file path=ppt/slides/slide37.xml><?xml version="1.0" encoding="utf-8"?>
+<file path=ppt/slides/slide38.xml><?xml version="1.0" encoding="utf-8"?>
 <p:sld xmlns:a="http://schemas.openxmlformats.org/drawingml/2006/main" xmlns:r="http://schemas.openxmlformats.org/officeDocument/2006/relationships" xmlns:p="http://schemas.openxmlformats.org/presentationml/2006/main">
   <p:cSld>
     <p:spTree>
@@ -36722,7 +37210,7 @@
           </a:ln>
           <a:extLst>
             <a:ext uri="{C572A759-6A51-4108-AA02-DFA0A04FC94B}">
-              <ma14:wrappingTextBoxFlag xmlns:ma14="http://schemas.microsoft.com/office/mac/drawingml/2011/main" xmlns:a14="http://schemas.microsoft.com/office/drawing/2010/main" xmlns:m="http://schemas.openxmlformats.org/officeDocument/2006/math" xmlns="" val="1"/>
+              <ma14:wrappingTextBoxFlag xmlns="" xmlns:m="http://schemas.openxmlformats.org/officeDocument/2006/math" xmlns:a14="http://schemas.microsoft.com/office/drawing/2010/main" xmlns:ma14="http://schemas.microsoft.com/office/mac/drawingml/2011/main" val="1"/>
             </a:ext>
           </a:extLst>
         </p:spPr>
@@ -37570,7 +38058,7 @@
 </p:sld>
 </file>
 
-<file path=ppt/slides/slide38.xml><?xml version="1.0" encoding="utf-8"?>
+<file path=ppt/slides/slide39.xml><?xml version="1.0" encoding="utf-8"?>
 <p:sld xmlns:a="http://schemas.openxmlformats.org/drawingml/2006/main" xmlns:r="http://schemas.openxmlformats.org/officeDocument/2006/relationships" xmlns:p="http://schemas.openxmlformats.org/presentationml/2006/main">
   <p:cSld>
     <p:spTree>
@@ -37688,7 +38176,7 @@
                 <a:tabLst/>
                 <a:defRPr/>
               </a:pPr>
-              <a:t>38</a:t>
+              <a:t>39</a:t>
             </a:fld>
             <a:endParaRPr kumimoji="0" lang="en-US" sz="1200" b="0" i="0" u="none" strike="noStrike" kern="1200" cap="none" spc="0" normalizeH="0" baseline="0" noProof="0">
               <a:ln>
@@ -41133,164 +41621,6 @@
 </p:sld>
 </file>
 
-<file path=ppt/slides/slide39.xml><?xml version="1.0" encoding="utf-8"?>
-<p:sld xmlns:a="http://schemas.openxmlformats.org/drawingml/2006/main" xmlns:r="http://schemas.openxmlformats.org/officeDocument/2006/relationships" xmlns:p="http://schemas.openxmlformats.org/presentationml/2006/main">
-  <p:cSld>
-    <p:spTree>
-      <p:nvGrpSpPr>
-        <p:cNvPr id="1" name=""/>
-        <p:cNvGrpSpPr/>
-        <p:nvPr/>
-      </p:nvGrpSpPr>
-      <p:grpSpPr>
-        <a:xfrm>
-          <a:off x="0" y="0"/>
-          <a:ext cx="0" cy="0"/>
-          <a:chOff x="0" y="0"/>
-          <a:chExt cx="0" cy="0"/>
-        </a:xfrm>
-      </p:grpSpPr>
-      <p:sp>
-        <p:nvSpPr>
-          <p:cNvPr id="2" name="Title 1">
-            <a:extLst>
-              <a:ext uri="{FF2B5EF4-FFF2-40B4-BE49-F238E27FC236}">
-                <a16:creationId xmlns:a16="http://schemas.microsoft.com/office/drawing/2014/main" id="{E743D407-5B53-49A7-9907-E801EA7FFD8E}"/>
-              </a:ext>
-            </a:extLst>
-          </p:cNvPr>
-          <p:cNvSpPr>
-            <a:spLocks noGrp="1"/>
-          </p:cNvSpPr>
-          <p:nvPr>
-            <p:ph type="title"/>
-          </p:nvPr>
-        </p:nvSpPr>
-        <p:spPr/>
-        <p:txBody>
-          <a:bodyPr/>
-          <a:lstStyle/>
-          <a:p>
-            <a:r>
-              <a:rPr lang="en-US" dirty="0"/>
-              <a:t>Review</a:t>
-            </a:r>
-          </a:p>
-        </p:txBody>
-      </p:sp>
-      <p:sp>
-        <p:nvSpPr>
-          <p:cNvPr id="3" name="Content Placeholder 2">
-            <a:extLst>
-              <a:ext uri="{FF2B5EF4-FFF2-40B4-BE49-F238E27FC236}">
-                <a16:creationId xmlns:a16="http://schemas.microsoft.com/office/drawing/2014/main" id="{AC300E2B-BFD0-4090-AFC5-FE82683F997F}"/>
-              </a:ext>
-            </a:extLst>
-          </p:cNvPr>
-          <p:cNvSpPr>
-            <a:spLocks noGrp="1"/>
-          </p:cNvSpPr>
-          <p:nvPr>
-            <p:ph idx="1"/>
-          </p:nvPr>
-        </p:nvSpPr>
-        <p:spPr>
-          <a:xfrm>
-            <a:off x="838199" y="1500160"/>
-            <a:ext cx="8434137" cy="4351338"/>
-          </a:xfrm>
-        </p:spPr>
-        <p:txBody>
-          <a:bodyPr>
-            <a:normAutofit/>
-          </a:bodyPr>
-          <a:lstStyle/>
-          <a:p>
-            <a:r>
-              <a:rPr lang="en-US" dirty="0"/>
-              <a:t>You should now be prepared to:</a:t>
-            </a:r>
-          </a:p>
-          <a:p>
-            <a:pPr lvl="1"/>
-            <a:r>
-              <a:rPr lang="en-US" dirty="0"/>
-              <a:t>Explain the difference between JS run-to-completion semantics and interrupt-based semantics.</a:t>
-            </a:r>
-          </a:p>
-          <a:p>
-            <a:pPr lvl="1"/>
-            <a:r>
-              <a:rPr lang="en-US" dirty="0"/>
-              <a:t>Given a simple program using async/await, work out the possible orders in which the statements in the program will run.</a:t>
-            </a:r>
-          </a:p>
-          <a:p>
-            <a:pPr lvl="1"/>
-            <a:r>
-              <a:rPr lang="en-US" dirty="0"/>
-              <a:t>Write simple programs that create and manage promises using async/await</a:t>
-            </a:r>
-          </a:p>
-          <a:p>
-            <a:pPr lvl="1"/>
-            <a:r>
-              <a:rPr lang="en-US" dirty="0"/>
-              <a:t>Write simple programs to mask latency with concurrency by using non-blocking IO and </a:t>
-            </a:r>
-            <a:r>
-              <a:rPr lang="en-US" dirty="0" err="1"/>
-              <a:t>Promise.all</a:t>
-            </a:r>
-            <a:r>
-              <a:rPr lang="en-US" dirty="0"/>
-              <a:t> in TypeScript.</a:t>
-            </a:r>
-          </a:p>
-        </p:txBody>
-      </p:sp>
-      <p:sp>
-        <p:nvSpPr>
-          <p:cNvPr id="4" name="Slide Number Placeholder 3">
-            <a:extLst>
-              <a:ext uri="{FF2B5EF4-FFF2-40B4-BE49-F238E27FC236}">
-                <a16:creationId xmlns:a16="http://schemas.microsoft.com/office/drawing/2014/main" id="{B7BF3F82-6F96-41E0-9C15-23CE00076176}"/>
-              </a:ext>
-            </a:extLst>
-          </p:cNvPr>
-          <p:cNvSpPr>
-            <a:spLocks noGrp="1"/>
-          </p:cNvSpPr>
-          <p:nvPr>
-            <p:ph type="sldNum" sz="quarter" idx="12"/>
-          </p:nvPr>
-        </p:nvSpPr>
-        <p:spPr/>
-        <p:txBody>
-          <a:bodyPr/>
-          <a:lstStyle/>
-          <a:p>
-            <a:fld id="{20F37917-FD3A-4669-9018-DA04BCDD3D75}" type="slidenum">
-              <a:rPr lang="en-US" smtClean="0"/>
-              <a:t>39</a:t>
-            </a:fld>
-            <a:endParaRPr lang="en-US"/>
-          </a:p>
-        </p:txBody>
-      </p:sp>
-    </p:spTree>
-    <p:extLst>
-      <p:ext uri="{BB962C8B-B14F-4D97-AF65-F5344CB8AC3E}">
-        <p14:creationId xmlns:p14="http://schemas.microsoft.com/office/powerpoint/2010/main" val="2457417242"/>
-      </p:ext>
-    </p:extLst>
-  </p:cSld>
-  <p:clrMapOvr>
-    <a:masterClrMapping/>
-  </p:clrMapOvr>
-</p:sld>
-</file>
-
 <file path=ppt/slides/slide4.xml><?xml version="1.0" encoding="utf-8"?>
 <p:sld xmlns:a="http://schemas.openxmlformats.org/drawingml/2006/main" xmlns:r="http://schemas.openxmlformats.org/officeDocument/2006/relationships" xmlns:p="http://schemas.openxmlformats.org/presentationml/2006/main">
   <p:cSld>
@@ -41459,7 +41789,7 @@
           </a:prstGeom>
           <a:extLst>
             <a:ext uri="{C572A759-6A51-4108-AA02-DFA0A04FC94B}">
-              <ma14:wrappingTextBoxFlag xmlns="" xmlns:m="http://schemas.openxmlformats.org/officeDocument/2006/math" xmlns:a14="http://schemas.microsoft.com/office/drawing/2010/main" xmlns:ma14="http://schemas.microsoft.com/office/mac/drawingml/2011/main" val="1"/>
+              <ma14:wrappingTextBoxFlag xmlns:ma14="http://schemas.microsoft.com/office/mac/drawingml/2011/main" xmlns:a14="http://schemas.microsoft.com/office/drawing/2010/main" xmlns:m="http://schemas.openxmlformats.org/officeDocument/2006/math" xmlns="" val="1"/>
             </a:ext>
           </a:extLst>
         </p:spPr>
@@ -41849,7 +42179,7 @@
               </a:effectLst>
               <a:extLst>
                 <a:ext uri="{C572A759-6A51-4108-AA02-DFA0A04FC94B}">
-                  <ma14:wrappingTextBoxFlag xmlns="" xmlns:m="http://schemas.openxmlformats.org/officeDocument/2006/math" xmlns:a14="http://schemas.microsoft.com/office/drawing/2010/main" xmlns:ma14="http://schemas.microsoft.com/office/mac/drawingml/2011/main" val="1"/>
+                  <ma14:wrappingTextBoxFlag xmlns:ma14="http://schemas.microsoft.com/office/mac/drawingml/2011/main" xmlns:a14="http://schemas.microsoft.com/office/drawing/2010/main" xmlns:m="http://schemas.openxmlformats.org/officeDocument/2006/math" xmlns="" val="1"/>
                 </a:ext>
               </a:extLst>
             </p:spPr>
@@ -41919,7 +42249,7 @@
               </a:effectLst>
               <a:extLst>
                 <a:ext uri="{C572A759-6A51-4108-AA02-DFA0A04FC94B}">
-                  <ma14:wrappingTextBoxFlag xmlns="" xmlns:m="http://schemas.openxmlformats.org/officeDocument/2006/math" xmlns:a14="http://schemas.microsoft.com/office/drawing/2010/main" xmlns:ma14="http://schemas.microsoft.com/office/mac/drawingml/2011/main" val="1"/>
+                  <ma14:wrappingTextBoxFlag xmlns:ma14="http://schemas.microsoft.com/office/mac/drawingml/2011/main" xmlns:a14="http://schemas.microsoft.com/office/drawing/2010/main" xmlns:m="http://schemas.openxmlformats.org/officeDocument/2006/math" xmlns="" val="1"/>
                 </a:ext>
               </a:extLst>
             </p:spPr>
@@ -41987,7 +42317,7 @@
               </a:effectLst>
               <a:extLst>
                 <a:ext uri="{C572A759-6A51-4108-AA02-DFA0A04FC94B}">
-                  <ma14:wrappingTextBoxFlag xmlns="" xmlns:m="http://schemas.openxmlformats.org/officeDocument/2006/math" xmlns:a14="http://schemas.microsoft.com/office/drawing/2010/main" xmlns:ma14="http://schemas.microsoft.com/office/mac/drawingml/2011/main" val="1"/>
+                  <ma14:wrappingTextBoxFlag xmlns:ma14="http://schemas.microsoft.com/office/mac/drawingml/2011/main" xmlns:a14="http://schemas.microsoft.com/office/drawing/2010/main" xmlns:m="http://schemas.openxmlformats.org/officeDocument/2006/math" xmlns="" val="1"/>
                 </a:ext>
               </a:extLst>
             </p:spPr>
@@ -42075,7 +42405,7 @@
                 </a:effectLst>
                 <a:extLst>
                   <a:ext uri="{C572A759-6A51-4108-AA02-DFA0A04FC94B}">
-                    <ma14:wrappingTextBoxFlag xmlns="" xmlns:m="http://schemas.openxmlformats.org/officeDocument/2006/math" xmlns:a14="http://schemas.microsoft.com/office/drawing/2010/main" xmlns:ma14="http://schemas.microsoft.com/office/mac/drawingml/2011/main" val="1"/>
+                    <ma14:wrappingTextBoxFlag xmlns:ma14="http://schemas.microsoft.com/office/mac/drawingml/2011/main" xmlns:a14="http://schemas.microsoft.com/office/drawing/2010/main" xmlns:m="http://schemas.openxmlformats.org/officeDocument/2006/math" xmlns="" val="1"/>
                   </a:ext>
                 </a:extLst>
               </p:spPr>
@@ -42253,7 +42583,7 @@
                   <a:effectLst/>
                   <a:extLst>
                     <a:ext uri="{C572A759-6A51-4108-AA02-DFA0A04FC94B}">
-                      <ma14:wrappingTextBoxFlag xmlns="" xmlns:m="http://schemas.openxmlformats.org/officeDocument/2006/math" xmlns:a14="http://schemas.microsoft.com/office/drawing/2010/main" xmlns:ma14="http://schemas.microsoft.com/office/mac/drawingml/2011/main" val="1"/>
+                      <ma14:wrappingTextBoxFlag xmlns:ma14="http://schemas.microsoft.com/office/mac/drawingml/2011/main" xmlns:a14="http://schemas.microsoft.com/office/drawing/2010/main" xmlns:m="http://schemas.openxmlformats.org/officeDocument/2006/math" xmlns="" val="1"/>
                     </a:ext>
                   </a:extLst>
                 </p:spPr>
@@ -42453,7 +42783,7 @@
                   <a:effectLst/>
                   <a:extLst>
                     <a:ext uri="{C572A759-6A51-4108-AA02-DFA0A04FC94B}">
-                      <ma14:wrappingTextBoxFlag xmlns="" xmlns:m="http://schemas.openxmlformats.org/officeDocument/2006/math" xmlns:a14="http://schemas.microsoft.com/office/drawing/2010/main" xmlns:ma14="http://schemas.microsoft.com/office/mac/drawingml/2011/main" val="1"/>
+                      <ma14:wrappingTextBoxFlag xmlns:ma14="http://schemas.microsoft.com/office/mac/drawingml/2011/main" xmlns:a14="http://schemas.microsoft.com/office/drawing/2010/main" xmlns:m="http://schemas.openxmlformats.org/officeDocument/2006/math" xmlns="" val="1"/>
                     </a:ext>
                   </a:extLst>
                 </p:spPr>
@@ -42543,7 +42873,7 @@
                 </a:effectLst>
                 <a:extLst>
                   <a:ext uri="{C572A759-6A51-4108-AA02-DFA0A04FC94B}">
-                    <ma14:wrappingTextBoxFlag xmlns="" xmlns:m="http://schemas.openxmlformats.org/officeDocument/2006/math" xmlns:a14="http://schemas.microsoft.com/office/drawing/2010/main" xmlns:ma14="http://schemas.microsoft.com/office/mac/drawingml/2011/main" val="1"/>
+                    <ma14:wrappingTextBoxFlag xmlns:ma14="http://schemas.microsoft.com/office/mac/drawingml/2011/main" xmlns:a14="http://schemas.microsoft.com/office/drawing/2010/main" xmlns:m="http://schemas.openxmlformats.org/officeDocument/2006/math" xmlns="" val="1"/>
                   </a:ext>
                 </a:extLst>
               </p:spPr>
@@ -42721,7 +43051,7 @@
                   <a:effectLst/>
                   <a:extLst>
                     <a:ext uri="{C572A759-6A51-4108-AA02-DFA0A04FC94B}">
-                      <ma14:wrappingTextBoxFlag xmlns="" xmlns:m="http://schemas.openxmlformats.org/officeDocument/2006/math" xmlns:a14="http://schemas.microsoft.com/office/drawing/2010/main" xmlns:ma14="http://schemas.microsoft.com/office/mac/drawingml/2011/main" val="1"/>
+                      <ma14:wrappingTextBoxFlag xmlns:ma14="http://schemas.microsoft.com/office/mac/drawingml/2011/main" xmlns:a14="http://schemas.microsoft.com/office/drawing/2010/main" xmlns:m="http://schemas.openxmlformats.org/officeDocument/2006/math" xmlns="" val="1"/>
                     </a:ext>
                   </a:extLst>
                 </p:spPr>
@@ -42811,7 +43141,7 @@
                 </a:effectLst>
                 <a:extLst>
                   <a:ext uri="{C572A759-6A51-4108-AA02-DFA0A04FC94B}">
-                    <ma14:wrappingTextBoxFlag xmlns="" xmlns:m="http://schemas.openxmlformats.org/officeDocument/2006/math" xmlns:a14="http://schemas.microsoft.com/office/drawing/2010/main" xmlns:ma14="http://schemas.microsoft.com/office/mac/drawingml/2011/main" val="1"/>
+                    <ma14:wrappingTextBoxFlag xmlns:ma14="http://schemas.microsoft.com/office/mac/drawingml/2011/main" xmlns:a14="http://schemas.microsoft.com/office/drawing/2010/main" xmlns:m="http://schemas.openxmlformats.org/officeDocument/2006/math" xmlns="" val="1"/>
                   </a:ext>
                 </a:extLst>
               </p:spPr>
@@ -42989,7 +43319,7 @@
                   <a:effectLst/>
                   <a:extLst>
                     <a:ext uri="{C572A759-6A51-4108-AA02-DFA0A04FC94B}">
-                      <ma14:wrappingTextBoxFlag xmlns="" xmlns:m="http://schemas.openxmlformats.org/officeDocument/2006/math" xmlns:a14="http://schemas.microsoft.com/office/drawing/2010/main" xmlns:ma14="http://schemas.microsoft.com/office/mac/drawingml/2011/main" val="1"/>
+                      <ma14:wrappingTextBoxFlag xmlns:ma14="http://schemas.microsoft.com/office/mac/drawingml/2011/main" xmlns:a14="http://schemas.microsoft.com/office/drawing/2010/main" xmlns:m="http://schemas.openxmlformats.org/officeDocument/2006/math" xmlns="" val="1"/>
                     </a:ext>
                   </a:extLst>
                 </p:spPr>
@@ -43060,7 +43390,7 @@
             </a:effectLst>
             <a:extLst>
               <a:ext uri="{C572A759-6A51-4108-AA02-DFA0A04FC94B}">
-                <ma14:wrappingTextBoxFlag xmlns="" xmlns:m="http://schemas.openxmlformats.org/officeDocument/2006/math" xmlns:a14="http://schemas.microsoft.com/office/drawing/2010/main" xmlns:ma14="http://schemas.microsoft.com/office/mac/drawingml/2011/main" val="1"/>
+                <ma14:wrappingTextBoxFlag xmlns:ma14="http://schemas.microsoft.com/office/mac/drawingml/2011/main" xmlns:a14="http://schemas.microsoft.com/office/drawing/2010/main" xmlns:m="http://schemas.openxmlformats.org/officeDocument/2006/math" xmlns="" val="1"/>
               </a:ext>
             </a:extLst>
           </p:spPr>
@@ -43287,7 +43617,7 @@
           </a:prstGeom>
           <a:extLst>
             <a:ext uri="{C572A759-6A51-4108-AA02-DFA0A04FC94B}">
-              <ma14:wrappingTextBoxFlag xmlns="" xmlns:m="http://schemas.openxmlformats.org/officeDocument/2006/math" xmlns:a14="http://schemas.microsoft.com/office/drawing/2010/main" xmlns:ma14="http://schemas.microsoft.com/office/mac/drawingml/2011/main" val="1"/>
+              <ma14:wrappingTextBoxFlag xmlns:ma14="http://schemas.microsoft.com/office/mac/drawingml/2011/main" xmlns:a14="http://schemas.microsoft.com/office/drawing/2010/main" xmlns:m="http://schemas.openxmlformats.org/officeDocument/2006/math" xmlns="" val="1"/>
             </a:ext>
           </a:extLst>
         </p:spPr>
@@ -43828,6 +44158,164 @@
       <p:bldP spid="7" grpId="0"/>
     </p:bldLst>
   </p:timing>
+</p:sld>
+</file>
+
+<file path=ppt/slides/slide40.xml><?xml version="1.0" encoding="utf-8"?>
+<p:sld xmlns:a="http://schemas.openxmlformats.org/drawingml/2006/main" xmlns:r="http://schemas.openxmlformats.org/officeDocument/2006/relationships" xmlns:p="http://schemas.openxmlformats.org/presentationml/2006/main">
+  <p:cSld>
+    <p:spTree>
+      <p:nvGrpSpPr>
+        <p:cNvPr id="1" name=""/>
+        <p:cNvGrpSpPr/>
+        <p:nvPr/>
+      </p:nvGrpSpPr>
+      <p:grpSpPr>
+        <a:xfrm>
+          <a:off x="0" y="0"/>
+          <a:ext cx="0" cy="0"/>
+          <a:chOff x="0" y="0"/>
+          <a:chExt cx="0" cy="0"/>
+        </a:xfrm>
+      </p:grpSpPr>
+      <p:sp>
+        <p:nvSpPr>
+          <p:cNvPr id="2" name="Title 1">
+            <a:extLst>
+              <a:ext uri="{FF2B5EF4-FFF2-40B4-BE49-F238E27FC236}">
+                <a16:creationId xmlns:a16="http://schemas.microsoft.com/office/drawing/2014/main" id="{E743D407-5B53-49A7-9907-E801EA7FFD8E}"/>
+              </a:ext>
+            </a:extLst>
+          </p:cNvPr>
+          <p:cNvSpPr>
+            <a:spLocks noGrp="1"/>
+          </p:cNvSpPr>
+          <p:nvPr>
+            <p:ph type="title"/>
+          </p:nvPr>
+        </p:nvSpPr>
+        <p:spPr/>
+        <p:txBody>
+          <a:bodyPr/>
+          <a:lstStyle/>
+          <a:p>
+            <a:r>
+              <a:rPr lang="en-US" dirty="0"/>
+              <a:t>Review</a:t>
+            </a:r>
+          </a:p>
+        </p:txBody>
+      </p:sp>
+      <p:sp>
+        <p:nvSpPr>
+          <p:cNvPr id="3" name="Content Placeholder 2">
+            <a:extLst>
+              <a:ext uri="{FF2B5EF4-FFF2-40B4-BE49-F238E27FC236}">
+                <a16:creationId xmlns:a16="http://schemas.microsoft.com/office/drawing/2014/main" id="{AC300E2B-BFD0-4090-AFC5-FE82683F997F}"/>
+              </a:ext>
+            </a:extLst>
+          </p:cNvPr>
+          <p:cNvSpPr>
+            <a:spLocks noGrp="1"/>
+          </p:cNvSpPr>
+          <p:nvPr>
+            <p:ph idx="1"/>
+          </p:nvPr>
+        </p:nvSpPr>
+        <p:spPr>
+          <a:xfrm>
+            <a:off x="838199" y="1500160"/>
+            <a:ext cx="8434137" cy="4351338"/>
+          </a:xfrm>
+        </p:spPr>
+        <p:txBody>
+          <a:bodyPr>
+            <a:normAutofit/>
+          </a:bodyPr>
+          <a:lstStyle/>
+          <a:p>
+            <a:r>
+              <a:rPr lang="en-US" dirty="0"/>
+              <a:t>You should now be prepared to:</a:t>
+            </a:r>
+          </a:p>
+          <a:p>
+            <a:pPr lvl="1"/>
+            <a:r>
+              <a:rPr lang="en-US" dirty="0"/>
+              <a:t>Explain the difference between JS run-to-completion semantics and interrupt-based semantics.</a:t>
+            </a:r>
+          </a:p>
+          <a:p>
+            <a:pPr lvl="1"/>
+            <a:r>
+              <a:rPr lang="en-US" dirty="0"/>
+              <a:t>Given a simple program using async/await, work out the possible orders in which the statements in the program will run.</a:t>
+            </a:r>
+          </a:p>
+          <a:p>
+            <a:pPr lvl="1"/>
+            <a:r>
+              <a:rPr lang="en-US" dirty="0"/>
+              <a:t>Write simple programs that create and manage promises using async/await</a:t>
+            </a:r>
+          </a:p>
+          <a:p>
+            <a:pPr lvl="1"/>
+            <a:r>
+              <a:rPr lang="en-US" dirty="0"/>
+              <a:t>Write simple programs to mask latency with concurrency by using non-blocking IO and </a:t>
+            </a:r>
+            <a:r>
+              <a:rPr lang="en-US" dirty="0" err="1"/>
+              <a:t>Promise.all</a:t>
+            </a:r>
+            <a:r>
+              <a:rPr lang="en-US" dirty="0"/>
+              <a:t> in TypeScript.</a:t>
+            </a:r>
+          </a:p>
+        </p:txBody>
+      </p:sp>
+      <p:sp>
+        <p:nvSpPr>
+          <p:cNvPr id="4" name="Slide Number Placeholder 3">
+            <a:extLst>
+              <a:ext uri="{FF2B5EF4-FFF2-40B4-BE49-F238E27FC236}">
+                <a16:creationId xmlns:a16="http://schemas.microsoft.com/office/drawing/2014/main" id="{B7BF3F82-6F96-41E0-9C15-23CE00076176}"/>
+              </a:ext>
+            </a:extLst>
+          </p:cNvPr>
+          <p:cNvSpPr>
+            <a:spLocks noGrp="1"/>
+          </p:cNvSpPr>
+          <p:nvPr>
+            <p:ph type="sldNum" sz="quarter" idx="12"/>
+          </p:nvPr>
+        </p:nvSpPr>
+        <p:spPr/>
+        <p:txBody>
+          <a:bodyPr/>
+          <a:lstStyle/>
+          <a:p>
+            <a:fld id="{20F37917-FD3A-4669-9018-DA04BCDD3D75}" type="slidenum">
+              <a:rPr lang="en-US" smtClean="0"/>
+              <a:t>40</a:t>
+            </a:fld>
+            <a:endParaRPr lang="en-US"/>
+          </a:p>
+        </p:txBody>
+      </p:sp>
+    </p:spTree>
+    <p:extLst>
+      <p:ext uri="{BB962C8B-B14F-4D97-AF65-F5344CB8AC3E}">
+        <p14:creationId xmlns:p14="http://schemas.microsoft.com/office/powerpoint/2010/main" val="2457417242"/>
+      </p:ext>
+    </p:extLst>
+  </p:cSld>
+  <p:clrMapOvr>
+    <a:masterClrMapping/>
+  </p:clrMapOvr>
 </p:sld>
 </file>
 

</xml_diff>